<commit_message>
Split BBL HERO rows by FACE/BODY on Korean laser page
Co-Authored-By: Claude Opus 5.5 <noreply@anthropic.com>
Claude-Session: https://claude.ai/code/session_01Xt33gB2BKshCcgATTv7RYP
</commit_message>
<xml_diff>
--- a/국문_수정/26.10_국문_전체(8페이지 BBL HERO·서브시전 추가).pptx
+++ b/국문_수정/26.10_국문_전체(8페이지 BBL HERO·서브시전 추가).pptx
@@ -38947,7 +38947,7 @@
         </p:nvGrpSpPr>
         <p:grpSpPr>
           <a:xfrm>
-            <a:off x="930580" y="8019471"/>
+            <a:off x="930580" y="7399320"/>
             <a:ext cx="8316077" cy="1600861"/>
             <a:chOff x="930580" y="4734845"/>
             <a:chExt cx="8316077" cy="1600861"/>
@@ -40082,7 +40082,7 @@
                 <a:ea typeface="신세계 Medium" panose="02000300000000000000" pitchFamily="50" charset="-127"/>
                 <a:cs typeface="Arial" pitchFamily="34" charset="-120"/>
               </a:rPr>
-              <a:t>BBL HERO 포에버영</a:t>
+              <a:t>BBL HERO (FACE)</a:t>
             </a:r>
           </a:p>
           <a:p>
@@ -40100,7 +40100,7 @@
                 <a:ea typeface="신세계 Regular" panose="02000300000000000000" pitchFamily="50" charset="-127"/>
                 <a:cs typeface="Arial" pitchFamily="34" charset="-120"/>
               </a:rPr>
-              <a:t>콜라겐 생성 자극 · 색소침착 개선 · 노화된 DNA 회춘 안티에이징</a:t>
+              <a:t>명품 하이엔드 광치료 · 1회 기준</a:t>
             </a:r>
           </a:p>
         </p:txBody>
@@ -40113,8 +40113,8 @@
         </p:nvSpPr>
         <p:spPr>
           <a:xfrm>
-            <a:off x="5946656" y="4865236"/>
-            <a:ext cx="3300000" cy="620151"/>
+            <a:off x="4389120" y="4865236"/>
+            <a:ext cx="1750000" cy="620151"/>
           </a:xfrm>
           <a:prstGeom prst="rect">
             <a:avLst/>
@@ -40128,7 +40128,6 @@
           </a:bodyPr>
           <a:lstStyle/>
           <a:p>
-            <a:pPr algn="r"/>
             <a:r>
               <a:rPr lang="ko-KR" altLang="en-US" sz="1200" dirty="0">
                 <a:solidFill>
@@ -40138,7 +40137,7 @@
                 <a:ea typeface="신세계 Regular" panose="02000300000000000000" pitchFamily="50" charset="-127"/>
                 <a:cs typeface="Arial" pitchFamily="34" charset="-120"/>
               </a:rPr>
-              <a:t xml:space="preserve">FACE (피부결 · 피부톤) 1회 </a:t>
+              <a:t xml:space="preserve">포에버영 </a:t>
             </a:r>
             <a:r>
               <a:rPr lang="ko-KR" altLang="en-US" sz="1400" dirty="0">
@@ -40152,8 +40151,31 @@
               <a:t>550,000</a:t>
             </a:r>
           </a:p>
+        </p:txBody>
+      </p:sp>
+      <p:sp>
+        <p:nvSpPr>
+          <p:cNvPr id="228" name="Text 15"/>
+          <p:cNvSpPr txBox="1"/>
+          <p:nvPr/>
+        </p:nvSpPr>
+        <p:spPr>
+          <a:xfrm>
+            <a:off x="6053328" y="4865236"/>
+            <a:ext cx="1750000" cy="620151"/>
+          </a:xfrm>
+          <a:prstGeom prst="rect">
+            <a:avLst/>
+          </a:prstGeom>
+          <a:noFill/>
+          <a:ln/>
+        </p:spPr>
+        <p:txBody>
+          <a:bodyPr wrap="none" lIns="0" tIns="0" rIns="0" bIns="0" rtlCol="0" anchor="ctr" anchorCtr="0">
+            <a:normAutofit/>
+          </a:bodyPr>
+          <a:lstStyle/>
           <a:p>
-            <a:pPr algn="r"/>
             <a:r>
               <a:rPr lang="ko-KR" altLang="en-US" sz="1200" dirty="0">
                 <a:solidFill>
@@ -40163,7 +40185,7 @@
                 <a:ea typeface="신세계 Regular" panose="02000300000000000000" pitchFamily="50" charset="-127"/>
                 <a:cs typeface="Arial" pitchFamily="34" charset="-120"/>
               </a:rPr>
-              <a:t xml:space="preserve">BODY (DNA 회춘) 1회 </a:t>
+              <a:t xml:space="preserve">스킨타이트 </a:t>
             </a:r>
             <a:r>
               <a:rPr lang="ko-KR" altLang="en-US" sz="1400" dirty="0">
@@ -40174,14 +40196,62 @@
                 <a:ea typeface="신세계 Bold" panose="02000300000000000000" pitchFamily="50" charset="-127"/>
                 <a:cs typeface="Arial" pitchFamily="34" charset="-120"/>
               </a:rPr>
-              <a:t>800,000</a:t>
+              <a:t>550,000</a:t>
             </a:r>
           </a:p>
         </p:txBody>
       </p:sp>
       <p:sp>
         <p:nvSpPr>
-          <p:cNvPr id="228" name="Shape 7"/>
+          <p:cNvPr id="229" name="Text 15"/>
+          <p:cNvSpPr txBox="1"/>
+          <p:nvPr/>
+        </p:nvSpPr>
+        <p:spPr>
+          <a:xfrm>
+            <a:off x="7918704" y="4865236"/>
+            <a:ext cx="1750000" cy="620151"/>
+          </a:xfrm>
+          <a:prstGeom prst="rect">
+            <a:avLst/>
+          </a:prstGeom>
+          <a:noFill/>
+          <a:ln/>
+        </p:spPr>
+        <p:txBody>
+          <a:bodyPr wrap="none" lIns="0" tIns="0" rIns="0" bIns="0" rtlCol="0" anchor="ctr" anchorCtr="0">
+            <a:normAutofit/>
+          </a:bodyPr>
+          <a:lstStyle/>
+          <a:p>
+            <a:r>
+              <a:rPr lang="ko-KR" altLang="en-US" sz="1200" dirty="0">
+                <a:solidFill>
+                  <a:srgbClr val="2498BD"/>
+                </a:solidFill>
+                <a:latin typeface="신세계 Regular" panose="02000300000000000000" pitchFamily="50" charset="-127"/>
+                <a:ea typeface="신세계 Regular" panose="02000300000000000000" pitchFamily="50" charset="-127"/>
+                <a:cs typeface="Arial" pitchFamily="34" charset="-120"/>
+              </a:rPr>
+              <a:t xml:space="preserve">클리어 </a:t>
+            </a:r>
+            <a:r>
+              <a:rPr lang="ko-KR" altLang="en-US" sz="1400" dirty="0">
+                <a:solidFill>
+                  <a:srgbClr val="1A1A1A"/>
+                </a:solidFill>
+                <a:latin typeface="신세계 Bold" panose="02000300000000000000" pitchFamily="50" charset="-127"/>
+                <a:ea typeface="신세계 Bold" panose="02000300000000000000" pitchFamily="50" charset="-127"/>
+                <a:cs typeface="Arial" pitchFamily="34" charset="-120"/>
+              </a:rPr>
+              <a:t>550,000</a:t>
+            </a:r>
+          </a:p>
+        </p:txBody>
+      </p:sp>
+      <p:sp>
+        <p:nvSpPr>
+          <p:cNvPr id="230" name="Shape 7"/>
           <p:cNvSpPr/>
           <p:nvPr/>
         </p:nvSpPr>
@@ -40201,7 +40271,7 @@
       </p:sp>
       <p:sp>
         <p:nvSpPr>
-          <p:cNvPr id="229" name="Text 11"/>
+          <p:cNvPr id="231" name="Text 11"/>
           <p:cNvSpPr txBox="1"/>
           <p:nvPr/>
         </p:nvSpPr>
@@ -40231,7 +40301,7 @@
                 <a:ea typeface="신세계 Medium" panose="02000300000000000000" pitchFamily="50" charset="-127"/>
                 <a:cs typeface="Arial" pitchFamily="34" charset="-120"/>
               </a:rPr>
-              <a:t>BBL HERO 스킨타이트</a:t>
+              <a:t>BBL HERO (BODY)</a:t>
             </a:r>
           </a:p>
           <a:p>
@@ -40249,21 +40319,21 @@
                 <a:ea typeface="신세계 Regular" panose="02000300000000000000" pitchFamily="50" charset="-127"/>
                 <a:cs typeface="Arial" pitchFamily="34" charset="-120"/>
               </a:rPr>
-              <a:t>피부 처짐 개선 · 콜라겐 생성 — 다운타임 · 통증 부담 없는 모공 · 잔주름 · 리프팅</a:t>
+              <a:t>가로 · 세로 15cm 혹은 부위별 · 1회 기준</a:t>
             </a:r>
           </a:p>
         </p:txBody>
       </p:sp>
       <p:sp>
         <p:nvSpPr>
-          <p:cNvPr id="230" name="Text 15"/>
+          <p:cNvPr id="232" name="Text 15"/>
           <p:cNvSpPr txBox="1"/>
           <p:nvPr/>
         </p:nvSpPr>
         <p:spPr>
           <a:xfrm>
-            <a:off x="5946656" y="5485387"/>
-            <a:ext cx="3300000" cy="620151"/>
+            <a:off x="4389120" y="5485387"/>
+            <a:ext cx="1750000" cy="620151"/>
           </a:xfrm>
           <a:prstGeom prst="rect">
             <a:avLst/>
@@ -40277,7 +40347,6 @@
           </a:bodyPr>
           <a:lstStyle/>
           <a:p>
-            <a:pPr algn="r"/>
             <a:r>
               <a:rPr lang="ko-KR" altLang="en-US" sz="1200" dirty="0">
                 <a:solidFill>
@@ -40287,32 +40356,7 @@
                 <a:ea typeface="신세계 Regular" panose="02000300000000000000" pitchFamily="50" charset="-127"/>
                 <a:cs typeface="Arial" pitchFamily="34" charset="-120"/>
               </a:rPr>
-              <a:t xml:space="preserve">FACE 1회 </a:t>
-            </a:r>
-            <a:r>
-              <a:rPr lang="ko-KR" altLang="en-US" sz="1400" dirty="0">
-                <a:solidFill>
-                  <a:srgbClr val="1A1A1A"/>
-                </a:solidFill>
-                <a:latin typeface="신세계 Bold" panose="02000300000000000000" pitchFamily="50" charset="-127"/>
-                <a:ea typeface="신세계 Bold" panose="02000300000000000000" pitchFamily="50" charset="-127"/>
-                <a:cs typeface="Arial" pitchFamily="34" charset="-120"/>
-              </a:rPr>
-              <a:t>550,000</a:t>
-            </a:r>
-          </a:p>
-          <a:p>
-            <a:pPr algn="r"/>
-            <a:r>
-              <a:rPr lang="ko-KR" altLang="en-US" sz="1200" dirty="0">
-                <a:solidFill>
-                  <a:srgbClr val="2498BD"/>
-                </a:solidFill>
-                <a:latin typeface="신세계 Regular" panose="02000300000000000000" pitchFamily="50" charset="-127"/>
-                <a:ea typeface="신세계 Regular" panose="02000300000000000000" pitchFamily="50" charset="-127"/>
-                <a:cs typeface="Arial" pitchFamily="34" charset="-120"/>
-              </a:rPr>
-              <a:t xml:space="preserve">BODY 1회 </a:t>
+              <a:t xml:space="preserve">포에버영 </a:t>
             </a:r>
             <a:r>
               <a:rPr lang="ko-KR" altLang="en-US" sz="1400" dirty="0">
@@ -40330,7 +40374,103 @@
       </p:sp>
       <p:sp>
         <p:nvSpPr>
-          <p:cNvPr id="231" name="Shape 7"/>
+          <p:cNvPr id="233" name="Text 15"/>
+          <p:cNvSpPr txBox="1"/>
+          <p:nvPr/>
+        </p:nvSpPr>
+        <p:spPr>
+          <a:xfrm>
+            <a:off x="6053328" y="5485387"/>
+            <a:ext cx="1750000" cy="620151"/>
+          </a:xfrm>
+          <a:prstGeom prst="rect">
+            <a:avLst/>
+          </a:prstGeom>
+          <a:noFill/>
+          <a:ln/>
+        </p:spPr>
+        <p:txBody>
+          <a:bodyPr wrap="none" lIns="0" tIns="0" rIns="0" bIns="0" rtlCol="0" anchor="ctr" anchorCtr="0">
+            <a:normAutofit/>
+          </a:bodyPr>
+          <a:lstStyle/>
+          <a:p>
+            <a:r>
+              <a:rPr lang="ko-KR" altLang="en-US" sz="1200" dirty="0">
+                <a:solidFill>
+                  <a:srgbClr val="2498BD"/>
+                </a:solidFill>
+                <a:latin typeface="신세계 Regular" panose="02000300000000000000" pitchFamily="50" charset="-127"/>
+                <a:ea typeface="신세계 Regular" panose="02000300000000000000" pitchFamily="50" charset="-127"/>
+                <a:cs typeface="Arial" pitchFamily="34" charset="-120"/>
+              </a:rPr>
+              <a:t xml:space="preserve">스킨타이트 </a:t>
+            </a:r>
+            <a:r>
+              <a:rPr lang="ko-KR" altLang="en-US" sz="1400" dirty="0">
+                <a:solidFill>
+                  <a:srgbClr val="1A1A1A"/>
+                </a:solidFill>
+                <a:latin typeface="신세계 Bold" panose="02000300000000000000" pitchFamily="50" charset="-127"/>
+                <a:ea typeface="신세계 Bold" panose="02000300000000000000" pitchFamily="50" charset="-127"/>
+                <a:cs typeface="Arial" pitchFamily="34" charset="-120"/>
+              </a:rPr>
+              <a:t>800,000</a:t>
+            </a:r>
+          </a:p>
+        </p:txBody>
+      </p:sp>
+      <p:sp>
+        <p:nvSpPr>
+          <p:cNvPr id="234" name="Text 15"/>
+          <p:cNvSpPr txBox="1"/>
+          <p:nvPr/>
+        </p:nvSpPr>
+        <p:spPr>
+          <a:xfrm>
+            <a:off x="7918704" y="5485387"/>
+            <a:ext cx="1750000" cy="620151"/>
+          </a:xfrm>
+          <a:prstGeom prst="rect">
+            <a:avLst/>
+          </a:prstGeom>
+          <a:noFill/>
+          <a:ln/>
+        </p:spPr>
+        <p:txBody>
+          <a:bodyPr wrap="none" lIns="0" tIns="0" rIns="0" bIns="0" rtlCol="0" anchor="ctr" anchorCtr="0">
+            <a:normAutofit/>
+          </a:bodyPr>
+          <a:lstStyle/>
+          <a:p>
+            <a:r>
+              <a:rPr lang="ko-KR" altLang="en-US" sz="1200" dirty="0">
+                <a:solidFill>
+                  <a:srgbClr val="2498BD"/>
+                </a:solidFill>
+                <a:latin typeface="신세계 Regular" panose="02000300000000000000" pitchFamily="50" charset="-127"/>
+                <a:ea typeface="신세계 Regular" panose="02000300000000000000" pitchFamily="50" charset="-127"/>
+                <a:cs typeface="Arial" pitchFamily="34" charset="-120"/>
+              </a:rPr>
+              <a:t xml:space="preserve">클리어 </a:t>
+            </a:r>
+            <a:r>
+              <a:rPr lang="ko-KR" altLang="en-US" sz="1400" dirty="0">
+                <a:solidFill>
+                  <a:srgbClr val="1A1A1A"/>
+                </a:solidFill>
+                <a:latin typeface="신세계 Bold" panose="02000300000000000000" pitchFamily="50" charset="-127"/>
+                <a:ea typeface="신세계 Bold" panose="02000300000000000000" pitchFamily="50" charset="-127"/>
+                <a:cs typeface="Arial" pitchFamily="34" charset="-120"/>
+              </a:rPr>
+              <a:t>800,000</a:t>
+            </a:r>
+          </a:p>
+        </p:txBody>
+      </p:sp>
+      <p:sp>
+        <p:nvSpPr>
+          <p:cNvPr id="235" name="Shape 7"/>
           <p:cNvSpPr/>
           <p:nvPr/>
         </p:nvSpPr>
@@ -40350,13 +40490,50 @@
       </p:sp>
       <p:sp>
         <p:nvSpPr>
-          <p:cNvPr id="232" name="Text 11"/>
+          <p:cNvPr id="236" name="Text 9"/>
           <p:cNvSpPr txBox="1"/>
           <p:nvPr/>
         </p:nvSpPr>
         <p:spPr>
           <a:xfrm>
-            <a:off x="1044692" y="6105538"/>
+            <a:off x="1044692" y="6165538"/>
+            <a:ext cx="8200000" cy="230000"/>
+          </a:xfrm>
+          <a:prstGeom prst="rect">
+            <a:avLst/>
+          </a:prstGeom>
+          <a:noFill/>
+          <a:ln/>
+        </p:spPr>
+        <p:txBody>
+          <a:bodyPr wrap="none" lIns="72000" tIns="0" rIns="72000" bIns="0" rtlCol="0" anchor="ctr" anchorCtr="0">
+            <a:normAutofit/>
+          </a:bodyPr>
+          <a:lstStyle/>
+          <a:p>
+            <a:r>
+              <a:rPr lang="ko-KR" altLang="en-US" sz="1000" dirty="0">
+                <a:solidFill>
+                  <a:srgbClr val="555555"/>
+                </a:solidFill>
+                <a:latin typeface="신세계 Regular" panose="02000300000000000000" pitchFamily="50" charset="-127"/>
+                <a:ea typeface="신세계 Regular" panose="02000300000000000000" pitchFamily="50" charset="-127"/>
+                <a:cs typeface="Arial" pitchFamily="34" charset="-120"/>
+              </a:rPr>
+              <a:t>* 포에버영 : 피부결 · 피부톤 (BODY는 DNA 회춘)   스킨타이트 : 모공 · 잔주름 · 리프팅   클리어 : 트러블</a:t>
+            </a:r>
+          </a:p>
+        </p:txBody>
+      </p:sp>
+      <p:sp>
+        <p:nvSpPr>
+          <p:cNvPr id="237" name="Text 11"/>
+          <p:cNvSpPr txBox="1"/>
+          <p:nvPr/>
+        </p:nvSpPr>
+        <p:spPr>
+          <a:xfrm>
+            <a:off x="1044692" y="8986574"/>
             <a:ext cx="5200000" cy="620151"/>
           </a:xfrm>
           <a:prstGeom prst="rect">
@@ -40380,7 +40557,7 @@
                 <a:ea typeface="신세계 Medium" panose="02000300000000000000" pitchFamily="50" charset="-127"/>
                 <a:cs typeface="Arial" pitchFamily="34" charset="-120"/>
               </a:rPr>
-              <a:t>BBL HERO 클리어</a:t>
+              <a:t>옵션) 서브시전 1부위 (손바닥 기준)</a:t>
             </a:r>
           </a:p>
           <a:p>
@@ -40398,20 +40575,20 @@
                 <a:ea typeface="신세계 Regular" panose="02000300000000000000" pitchFamily="50" charset="-127"/>
                 <a:cs typeface="Arial" pitchFamily="34" charset="-120"/>
               </a:rPr>
-              <a:t>트러블 케어 — 블루 · 옐로 · 레드 3단계 빛으로 여드름균 제거 · 염증 · 자국 개선</a:t>
+              <a:t>움푹 패인 여드름 흉터 아래 섬유화된 조직을 끊어 흉터를 차오르게 하는 시술</a:t>
             </a:r>
           </a:p>
         </p:txBody>
       </p:sp>
       <p:sp>
         <p:nvSpPr>
-          <p:cNvPr id="233" name="Text 15"/>
+          <p:cNvPr id="238" name="Text 15"/>
           <p:cNvSpPr txBox="1"/>
           <p:nvPr/>
         </p:nvSpPr>
         <p:spPr>
           <a:xfrm>
-            <a:off x="5946656" y="6105538"/>
+            <a:off x="5946656" y="8986574"/>
             <a:ext cx="3300000" cy="620151"/>
           </a:xfrm>
           <a:prstGeom prst="rect">
@@ -40436,192 +40613,6 @@
                 <a:ea typeface="신세계 Regular" panose="02000300000000000000" pitchFamily="50" charset="-127"/>
                 <a:cs typeface="Arial" pitchFamily="34" charset="-120"/>
               </a:rPr>
-              <a:t xml:space="preserve">FACE 1회 </a:t>
-            </a:r>
-            <a:r>
-              <a:rPr lang="ko-KR" altLang="en-US" sz="1400" dirty="0">
-                <a:solidFill>
-                  <a:srgbClr val="1A1A1A"/>
-                </a:solidFill>
-                <a:latin typeface="신세계 Bold" panose="02000300000000000000" pitchFamily="50" charset="-127"/>
-                <a:ea typeface="신세계 Bold" panose="02000300000000000000" pitchFamily="50" charset="-127"/>
-                <a:cs typeface="Arial" pitchFamily="34" charset="-120"/>
-              </a:rPr>
-              <a:t>550,000</a:t>
-            </a:r>
-          </a:p>
-          <a:p>
-            <a:pPr algn="r"/>
-            <a:r>
-              <a:rPr lang="ko-KR" altLang="en-US" sz="1200" dirty="0">
-                <a:solidFill>
-                  <a:srgbClr val="2498BD"/>
-                </a:solidFill>
-                <a:latin typeface="신세계 Regular" panose="02000300000000000000" pitchFamily="50" charset="-127"/>
-                <a:ea typeface="신세계 Regular" panose="02000300000000000000" pitchFamily="50" charset="-127"/>
-                <a:cs typeface="Arial" pitchFamily="34" charset="-120"/>
-              </a:rPr>
-              <a:t xml:space="preserve">BODY 1회 </a:t>
-            </a:r>
-            <a:r>
-              <a:rPr lang="ko-KR" altLang="en-US" sz="1400" dirty="0">
-                <a:solidFill>
-                  <a:srgbClr val="1A1A1A"/>
-                </a:solidFill>
-                <a:latin typeface="신세계 Bold" panose="02000300000000000000" pitchFamily="50" charset="-127"/>
-                <a:ea typeface="신세계 Bold" panose="02000300000000000000" pitchFamily="50" charset="-127"/>
-                <a:cs typeface="Arial" pitchFamily="34" charset="-120"/>
-              </a:rPr>
-              <a:t>800,000</a:t>
-            </a:r>
-          </a:p>
-        </p:txBody>
-      </p:sp>
-      <p:sp>
-        <p:nvSpPr>
-          <p:cNvPr id="234" name="Shape 7"/>
-          <p:cNvSpPr/>
-          <p:nvPr/>
-        </p:nvSpPr>
-        <p:spPr>
-          <a:xfrm>
-            <a:off x="1041515" y="6725689"/>
-            <a:ext cx="8205142" cy="13607"/>
-          </a:xfrm>
-          <a:prstGeom prst="rect">
-            <a:avLst/>
-          </a:prstGeom>
-          <a:solidFill>
-            <a:srgbClr val="CCCCCC"/>
-          </a:solidFill>
-          <a:ln/>
-        </p:spPr>
-      </p:sp>
-      <p:sp>
-        <p:nvSpPr>
-          <p:cNvPr id="235" name="Text 9"/>
-          <p:cNvSpPr txBox="1"/>
-          <p:nvPr/>
-        </p:nvSpPr>
-        <p:spPr>
-          <a:xfrm>
-            <a:off x="1044692" y="6785689"/>
-            <a:ext cx="5200000" cy="230000"/>
-          </a:xfrm>
-          <a:prstGeom prst="rect">
-            <a:avLst/>
-          </a:prstGeom>
-          <a:noFill/>
-          <a:ln/>
-        </p:spPr>
-        <p:txBody>
-          <a:bodyPr wrap="none" lIns="72000" tIns="0" rIns="72000" bIns="0" rtlCol="0" anchor="ctr" anchorCtr="0">
-            <a:normAutofit/>
-          </a:bodyPr>
-          <a:lstStyle/>
-          <a:p>
-            <a:r>
-              <a:rPr lang="ko-KR" altLang="en-US" sz="1000" dirty="0">
-                <a:solidFill>
-                  <a:srgbClr val="555555"/>
-                </a:solidFill>
-                <a:latin typeface="신세계 Regular" panose="02000300000000000000" pitchFamily="50" charset="-127"/>
-                <a:ea typeface="신세계 Regular" panose="02000300000000000000" pitchFamily="50" charset="-127"/>
-                <a:cs typeface="Arial" pitchFamily="34" charset="-120"/>
-              </a:rPr>
-              <a:t>* BBL HERO BODY : 가로 · 세로 15cm 혹은 부위별 기준</a:t>
-            </a:r>
-          </a:p>
-        </p:txBody>
-      </p:sp>
-      <p:sp>
-        <p:nvSpPr>
-          <p:cNvPr id="236" name="Text 11"/>
-          <p:cNvSpPr txBox="1"/>
-          <p:nvPr/>
-        </p:nvSpPr>
-        <p:spPr>
-          <a:xfrm>
-            <a:off x="1044692" y="9606725"/>
-            <a:ext cx="5200000" cy="620151"/>
-          </a:xfrm>
-          <a:prstGeom prst="rect">
-            <a:avLst/>
-          </a:prstGeom>
-          <a:noFill/>
-          <a:ln/>
-        </p:spPr>
-        <p:txBody>
-          <a:bodyPr wrap="none" lIns="72000" tIns="0" rIns="72000" bIns="0" rtlCol="0" anchor="ctr" anchorCtr="0">
-            <a:normAutofit/>
-          </a:bodyPr>
-          <a:lstStyle/>
-          <a:p>
-            <a:r>
-              <a:rPr lang="ko-KR" altLang="en-US" sz="1400" dirty="0">
-                <a:solidFill>
-                  <a:srgbClr val="555555"/>
-                </a:solidFill>
-                <a:latin typeface="신세계 Medium" panose="02000300000000000000" pitchFamily="50" charset="-127"/>
-                <a:ea typeface="신세계 Medium" panose="02000300000000000000" pitchFamily="50" charset="-127"/>
-                <a:cs typeface="Arial" pitchFamily="34" charset="-120"/>
-              </a:rPr>
-              <a:t>옵션) 서브시전 1부위 (손바닥 기준)</a:t>
-            </a:r>
-          </a:p>
-          <a:p>
-            <a:pPr>
-              <a:lnSpc>
-                <a:spcPct val="150000"/>
-              </a:lnSpc>
-            </a:pPr>
-            <a:r>
-              <a:rPr lang="ko-KR" altLang="en-US" sz="1000" dirty="0">
-                <a:solidFill>
-                  <a:srgbClr val="555555"/>
-                </a:solidFill>
-                <a:latin typeface="신세계 Regular" panose="02000300000000000000" pitchFamily="50" charset="-127"/>
-                <a:ea typeface="신세계 Regular" panose="02000300000000000000" pitchFamily="50" charset="-127"/>
-                <a:cs typeface="Arial" pitchFamily="34" charset="-120"/>
-              </a:rPr>
-              <a:t>움푹 패인 여드름 흉터 아래 섬유화된 조직을 끊어 흉터를 차오르게 하는 시술</a:t>
-            </a:r>
-          </a:p>
-        </p:txBody>
-      </p:sp>
-      <p:sp>
-        <p:nvSpPr>
-          <p:cNvPr id="237" name="Text 15"/>
-          <p:cNvSpPr txBox="1"/>
-          <p:nvPr/>
-        </p:nvSpPr>
-        <p:spPr>
-          <a:xfrm>
-            <a:off x="5946656" y="9606725"/>
-            <a:ext cx="3300000" cy="620151"/>
-          </a:xfrm>
-          <a:prstGeom prst="rect">
-            <a:avLst/>
-          </a:prstGeom>
-          <a:noFill/>
-          <a:ln/>
-        </p:spPr>
-        <p:txBody>
-          <a:bodyPr wrap="none" lIns="0" tIns="0" rIns="0" bIns="0" rtlCol="0" anchor="ctr" anchorCtr="0">
-            <a:normAutofit/>
-          </a:bodyPr>
-          <a:lstStyle/>
-          <a:p>
-            <a:pPr algn="r"/>
-            <a:r>
-              <a:rPr lang="ko-KR" altLang="en-US" sz="1200" dirty="0">
-                <a:solidFill>
-                  <a:srgbClr val="2498BD"/>
-                </a:solidFill>
-                <a:latin typeface="신세계 Regular" panose="02000300000000000000" pitchFamily="50" charset="-127"/>
-                <a:ea typeface="신세계 Regular" panose="02000300000000000000" pitchFamily="50" charset="-127"/>
-                <a:cs typeface="Arial" pitchFamily="34" charset="-120"/>
-              </a:rPr>
               <a:t xml:space="preserve">1회 </a:t>
             </a:r>
             <a:r>
@@ -40640,13 +40631,13 @@
       </p:sp>
       <p:sp>
         <p:nvSpPr>
-          <p:cNvPr id="238" name="Shape 7"/>
+          <p:cNvPr id="239" name="Shape 7"/>
           <p:cNvSpPr/>
           <p:nvPr/>
         </p:nvSpPr>
         <p:spPr>
           <a:xfrm>
-            <a:off x="1041515" y="10226876"/>
+            <a:off x="1041515" y="9606725"/>
             <a:ext cx="8205142" cy="13607"/>
           </a:xfrm>
           <a:prstGeom prst="rect">

</xml_diff>